<commit_message>
docs: align slide titles with the grading rubric
Every rubric section already had a dedicated slide; three titles now
carry the rubric's own words so they are impossible to miss when
grading: 'Introduction - The Problem', 'Architecture Diagram', and
'Limitations and Future Scope'.

Co-Authored-By: Claude Opus 5 <noreply@anthropic.com>
</commit_message>
<xml_diff>
--- a/presentation/MSML612_final_presentation.pptx
+++ b/presentation/MSML612_final_presentation.pptx
@@ -5269,7 +5269,7 @@
                 <a:ea typeface="Cambria" pitchFamily="34" charset="-122"/>
                 <a:cs typeface="Cambria" pitchFamily="34" charset="-120"/>
               </a:rPr>
-              <a:t>Limitations and Future Work</a:t>
+              <a:t>Limitations and Future Scope</a:t>
             </a:r>
             <a:endParaRPr lang="en-US" sz="3200" dirty="0"/>
           </a:p>
@@ -6208,7 +6208,7 @@
                 <a:ea typeface="Cambria" pitchFamily="34" charset="-122"/>
                 <a:cs typeface="Cambria" pitchFamily="34" charset="-120"/>
               </a:rPr>
-              <a:t>The Problem</a:t>
+              <a:t>Introduction — The Problem</a:t>
             </a:r>
             <a:endParaRPr lang="en-US" sz="3200" dirty="0"/>
           </a:p>
@@ -9256,7 +9256,7 @@
                 <a:ea typeface="Cambria" pitchFamily="34" charset="-122"/>
                 <a:cs typeface="Cambria" pitchFamily="34" charset="-120"/>
               </a:rPr>
-              <a:t>Architecture</a:t>
+              <a:t>Architecture Diagram</a:t>
             </a:r>
             <a:endParaRPr lang="en-US" sz="2800" dirty="0"/>
           </a:p>

</xml_diff>

<commit_message>
fix: repair generated notebook and correct claims in the deliverables
The notebook generator split cell text without keeping line terminators.
nbformat concatenates `source` with no separator, so every cell of the
committed notebook collapsed onto one line and each code cell raised
SyntaxError on execution. Split with keepends, and stamp the cell ids
that nbformat 4.5 requires.

Slide 10 stacked two figures 0.89" into each other, hiding the x-axis
and lower traces of the actual-vs-predicted plot.

Corrections to text that no longer matched the final run:

- report intro and notebook cited RMSE 0.46 kW, the superseded interim
  value; the final run is 0.4494
- Table 2 credited a mean-pooling ablation that was never run
- the 4.3/5.6 kW peak maxima are full-test-period figures but were
  attributed to Figure 4, which plots only the first two weeks
- Figure 2's caption pointed at a dashed line the plot does not draw,
  and slide 7's notes at learning-rate steps it does not show
</commit_message>
<xml_diff>
--- a/presentation/MSML612_final_presentation.pptx
+++ b/presentation/MSML612_final_presentation.pptx
@@ -610,7 +610,7 @@
               <a:t>10:30–11:30 · SPEAKER 3
 CUE: The defence against 'why is R² only 0.59?'. MSE makes hedging optimal; the fix is a quantile loss, not a bigger model. Say that explicitly.
 SCRIPT:
-Now the honest part — where the model still struggles. Look at the traces: it tracks the daily cycle and the timing of demand events well, but it consistently under-shoots peak height — predicted maxima around 4.3 kilowatts against observed peaks above 5.6. The residuals are right-skewed, and the scatter falls below the diagonal at high load. Every diagnostic points the same way: the model hedges toward the mean when demand is high.
+Now the honest part — where the model still struggles. Look at the traces: it tracks the daily cycle and the timing of demand events well, but it consistently under-shoots peak height. In the two weeks on screen the tallest actual hour reaches 3.8 kilowatts and we predict 2.6; across the whole test period it is 5.6 against 4.3. The residuals are right-skewed, and the scatter falls below the diagonal at high load. Every diagnostic points the same way: the model hedges toward the mean when demand is high.
 Here's the key point: that is rational behaviour under squared error, not a capacity failure. A confident peak prediction that lands an hour early gets punished twice — once for the missed peak, once for the false one. Hedging gets punished moderately either way. So MSE makes shrinking toward the mean optimal exactly where the data is most volatile. The fix isn't a bigger model — it's a quantile loss that can express uncertainty about peaks. That's our top-listed future work, and you'll see the behaviour live in the demo right now.</a:t>
             </a:r>
             <a:endParaRPr lang="en-US" dirty="0"/>
@@ -1628,7 +1628,7 @@
 CUE: REQUIRED PLOT — say 'training and validation loss versus epoch' out loud. The overfitting story is a strength: diagnosed on the interim curve, fixed in the final run shown here.
 SCRIPT:
 This is our training and validation loss versus epoch — the required plot — and it has a story. Our interim run trained a fixed twenty epochs. Validation loss bottomed out at epoch nine and then climbed for eleven epochs while training loss kept falling — textbook overfitting, visible right there in the curve.
-So the final training loop earns this slide: Adam with MSE on standardized targets, gradient clipping, a scheduler that halves the learning rate after three stalled epochs, and early stopping with patience eight. In the run you're looking at, validation bottomed at epoch eleven at 0.316, the learning-rate cuts are visible as steps in the curve, and training halted at nineteen instead of wasting eight more epochs memorizing the training set. The checkpoint we evaluate — and demo — is the epoch-eleven one.</a:t>
+So the final training loop earns this slide: Adam with MSE on standardized targets, gradient clipping, a scheduler that halves the learning rate after three stalled epochs, and early stopping with patience eight. In the run you're looking at, validation bottomed at epoch eleven at 0.316 — that's the marked point — and training halted at nineteen instead of wasting eight more epochs memorizing the training set. The checkpoint we evaluate — and demo — is the epoch-eleven one.</a:t>
             </a:r>
             <a:endParaRPr lang="en-US" dirty="0"/>
           </a:p>
@@ -2461,8 +2461,8 @@
         </p:blipFill>
         <p:spPr>
           <a:xfrm>
-            <a:off x="548640" y="1371600"/>
-            <a:ext cx="7315200" cy="3234050"/>
+            <a:off x="548640" y="1298448"/>
+            <a:ext cx="6217920" cy="2748942"/>
           </a:xfrm>
           <a:prstGeom prst="rect">
             <a:avLst/>
@@ -2485,8 +2485,8 @@
         </p:blipFill>
         <p:spPr>
           <a:xfrm>
-            <a:off x="548640" y="3794760"/>
-            <a:ext cx="7315200" cy="2926080"/>
+            <a:off x="548640" y="4160520"/>
+            <a:ext cx="6217920" cy="2487168"/>
           </a:xfrm>
           <a:prstGeom prst="rect">
             <a:avLst/>
@@ -2599,7 +2599,7 @@
                 <a:ea typeface="Calibri" pitchFamily="34" charset="-122"/>
                 <a:cs typeface="Calibri" pitchFamily="34" charset="-120"/>
               </a:rPr>
-              <a:t>The model tracks the daily cycle and event timing, but consistently under-shoots peak magnitude — predicted maxima reach 4.3 kW against observed 5.6 kW.</a:t>
+              <a:t>The model tracks the daily cycle and event timing, but consistently under-shoots peak magnitude — across the test period predicted maxima reach 4.27 kW against observed 5.63 kW.</a:t>
             </a:r>
             <a:endParaRPr lang="en-US" sz="1150" dirty="0"/>
           </a:p>

</xml_diff>

<commit_message>
Fix demo fallback, add PDF exports, assign speakers and demo origins
The demo no longer substitutes the superseded interim run silently. A run with
no results file raises an error in both tabs instead of presenting another
run's numbers as its own, the comparison row is labelled from the run's
recorded model type rather than hardcoded, and the horizon=1 forecast is
anchored to the last observed hour so it draws as a visible segment.

Deck notes now name the speaker per slide and carry the two verified demo
slider origins: 2556 (10 Aug 2010 05:00) and 5017 (20 Nov 2010 18:00, the
largest peak in the test set).

Adds PDF exports of the report and deck, and rewrites CHECKLIST.md with the
speaking split, the timing budget, and the limitations worth owning in Q&A.
</commit_message>
<xml_diff>
--- a/presentation/MSML612_final_presentation.pptx
+++ b/presentation/MSML612_final_presentation.pptx
@@ -516,7 +516,7 @@
           <a:p>
             <a:r>
               <a:rPr lang="en-US" dirty="0"/>
-              <a:t>0:00–0:30 · SPEAKER 1 (suggested: intro + data)
+              <a:t>0:00–0:30 · WILLIAM — intro + data (slides 1–3)
 CUE: Introduce team and topic in one line.
 SCRIPT:
 Good evening — we're William, Ciara, and Chris, and our project is forecasting household electricity demand one hour ahead with a Transformer. The one-line version: deep models in forecasting are often never compared to the forecast you get for free — so we built that comparison in from the start, and we'll show you a live demo of the model beating it.</a:t>
@@ -607,7 +607,7 @@
           <a:p>
             <a:r>
               <a:rPr lang="en-US" dirty="0"/>
-              <a:t>10:30–11:30 · SPEAKER 3
+              <a:t>10:30–11:30 · CHRIS
 CUE: The defence against 'why is R² only 0.59?'. MSE makes hedging optimal; the fix is a quantile loss, not a bigger model. Say that explicitly.
 SCRIPT:
 Now the honest part — where the model still struggles. Look at the traces: it tracks the daily cycle and the timing of demand events well, but it consistently under-shoots peak height. In the two weeks on screen the tallest actual hour reaches 3.8 kilowatts and we predict 2.6; across the whole test period it is 5.6 against 4.3. The residuals are right-skewed, and the scatter falls below the diagonal at high load. Every diagnostic points the same way: the model hedges toward the mean when demand is high.
@@ -699,14 +699,18 @@
           <a:p>
             <a:r>
               <a:rPr lang="en-US" dirty="0"/>
-              <a:t>11:30–14:00 · SPEAKER 3
+              <a:t>11:30–14:00 · CHRIS
 CUE: REQUIRED — 3 rubric points. App already running before the talk starts; never launch live. Two forecasts: calm overnight hour, then evening peak — own the weakness. Fallback video ready.
+SLIDER ORIGINS — verified, do not hunt live:
+  · CALM  = 2556  (10 Aug 2010, 05:00) — actual 0.314 kW, predicted 0.314, error 0.0002
+  · PEAK  = 5017  (20 Nov 2010, 18:00) — actual 5.627 kW, predicted 2.294, short by 3.33
+  (PEAK is the same 5.63 kW maximum quoted on slide 10 and in the report.)
+  Softer alternative if 5017 feels too brutal: 3843 (2 Oct 2010, 20:00), 3.94 vs 1.94.
 SCRIPT (alt-tab to the browser):
 This is the model you just saw evaluated, running live — the epoch-eleven checkpoint, forecasting from the held-out test period. I pick any moment with this slider; the model sees only the preceding 24 hours.
-First, a quiet overnight hour. [Set slider to a pre-chosen 3 a.m. origin.] Prediction, actual, absolute error — a few hundredths of a kilowatt. Routine load, and the model nails it.
-Now the hard case — an evening peak. [Set slider to the pre-chosen origin.] You can see exactly what the error analysis predicted: timing right, magnitude short. We're showing you the failure mode on purpose — it's systematic, we understand why it happens, and we know what fixes it.
-[Optional if time: Performance tab — the live-computed table matches slide 9.] [Alt-tab back to the deck.]
-REHEARSAL NOTE: choose and write down both slider origins beforehand; do not hunt for good examples live.</a:t>
+First, a quiet overnight hour. [Slider to 2556 — 10 August, 5 a.m.] Predicted 0.314 kilowatts, actual 0.314 — the error is two ten-thousandths of a kilowatt. Routine overnight load, and the model is essentially exact.
+Now the hard case — the single largest peak in the test set. [Slider to 5017 — 20 November, 6 p.m.] Actual 5.63 kilowatts; we predict 2.29. That is the 5.6 versus 4.3 gap from the results slide, in its worst instance. Timing right, magnitude short. We're showing you the failure mode on purpose — it's systematic, we understand why it happens, and we know that a quantile loss is what fixes it.
+[Optional if time: Performance tab — the live-computed table matches slide 9.] [Alt-tab back to the deck.]</a:t>
             </a:r>
             <a:endParaRPr lang="en-US" dirty="0"/>
           </a:p>
@@ -794,7 +798,7 @@
           <a:p>
             <a:r>
               <a:rPr lang="en-US" dirty="0"/>
-              <a:t>14:00–14:30 · SPEAKER 3
+              <a:t>14:00–14:30 · CHRIS
 CUE: The evidence the architecture was chosen rather than assumed — real weight under 'difficulty of NN design'.
 SCRIPT:
 Every row here is an independent train-and-evaluate cycle — one design decision changed at a time, everything else held fixed. Three takeaways. The calendar features matter most: dropping them costs more RMSE than any architecture change. More capacity only hurts — doubling depth or width makes things worse, so the constraint is data, not expressiveness, which is why our model is deliberately small. And the Transformer does beat a parameter-matched LSTM — 21.8 versus 20.3 percent skill. A real margin, and an honest one: every configuration in this grid still beats persistence by at least 19.6 percent, so the conclusion doesn't hinge on any single design choice.</a:t>
@@ -885,7 +889,7 @@
           <a:p>
             <a:r>
               <a:rPr lang="en-US" dirty="0"/>
-              <a:t>14:30–14:50 · SPEAKER 3
+              <a:t>14:30–14:50 · CHRIS
 CUE: Be brisk. The quantile-loss point is strongest — it follows directly from the error analysis.
 SCRIPT:
 Limitations, briefly and honestly: one household, so no claims about generalization. No weather data — temperature is the strongest known driver of residential demand and it isn't in this dataset, which caps achievable accuracy. And point forecasts only. That's why the top future-work item is a quantile loss — it attacks the peak-hedging you just watched — followed by weather features and multi-hour horizons, which the code already supports.</a:t>
@@ -976,7 +980,7 @@
           <a:p>
             <a:r>
               <a:rPr lang="en-US" dirty="0"/>
-              <a:t>14:50–15:00 · SPEAKER 3
+              <a:t>14:50–15:00 · CHRIS
 CUE: Do not read these. Leave up while transitioning to questions.
 SCRIPT:
 These are the works that shaped the design — happy to point at any of them in questions. Thank you — what would you like to ask?</a:t>
@@ -1160,7 +1164,7 @@
           <a:p>
             <a:r>
               <a:rPr lang="en-US" dirty="0"/>
-              <a:t>0:30–1:45 · SPEAKER 1
+              <a:t>0:30–1:45 · WILLIAM
 CUE: Aggregate-vs-household is why this is hard and why R² is not 0.95. Land the framing question: the bar is 'better than free', not 'low error'.
 SCRIPT:
 Why is this hard? Electricity can't be stored cheaply at grid scale, so supply has to match demand continuously — that's why short-term load forecasting drives generation scheduling, demand response, and battery dispatch. But there's a scale problem. National demand curves are smooth, because millions of appliance events average out. One household is the opposite: the series is spiky and heavy-tailed, dominated by a handful of discrete events — an oven, a washing machine, a water heater. The variance that matters operationally lives in those peaks, not in the daily rhythm.
@@ -1252,7 +1256,7 @@
           <a:p>
             <a:r>
               <a:rPr lang="en-US" dirty="0"/>
-              <a:t>1:45–3:15 · SPEAKER 1
+              <a:t>1:45–3:15 · WILLIAM
 CUE: Walk the pipeline quickly; spend the time on the split/scaling box — that is what a grader will probe. Expect a question here.
 SCRIPT:
 The data is the UCI Individual Household Electric Power Consumption set: one house near Paris, December 2006 to November 2010, seven electrical measurements every minute. About one and a quarter percent of rows have missing values, marked with question marks.
@@ -1345,7 +1349,7 @@
           <a:p>
             <a:r>
               <a:rPr lang="en-US" dirty="0"/>
-              <a:t>3:15–4:45 · SPEAKER 2 (suggested: solution + architecture)
+              <a:t>3:15–4:45 · CIARA — solution + architecture (slides 4–7)
 CUE: The novelty slide — 3 rubric points. Not 'we used a Transformer'; the argument is attention fits this data for a specific reason, and the evaluation could have proven us wrong.
 SCRIPT:
 Our solution has two halves, and the second is as deliberate as the first.
@@ -1438,7 +1442,7 @@
           <a:p>
             <a:r>
               <a:rPr lang="en-US" dirty="0"/>
-              <a:t>4:45–5:15 · SPEAKER 2
+              <a:t>4:45–5:15 · CIARA
 CUE: Move fast. One rubric point; do not dwell.
 SCRIPT:
 Quickly on tooling: PyTorch for the model and training loop, pandas and scikit-learn for the pipeline, matplotlib for figures, and Streamlit for the live demo you'll see in a few minutes. Everything is seeded and pinned, every training run writes a history file, and the whole repo reproduces from two commands — train, evaluate.</a:t>
@@ -1529,7 +1533,7 @@
           <a:p>
             <a:r>
               <a:rPr lang="en-US" dirty="0"/>
-              <a:t>5:15–7:00 · SPEAKER 2
+              <a:t>5:15–7:00 · CIARA
 CUE: Two rubric points — highest-value slide per second. Trace the path out loud, call out tensor shapes: they show you understand the data flow, not just the diagram.
 SCRIPT:
 Let me trace one batch through the diagram, with shapes.
@@ -1624,7 +1628,7 @@
           <a:p>
             <a:r>
               <a:rPr lang="en-US" dirty="0"/>
-              <a:t>7:00–8:15 · SPEAKER 2
+              <a:t>7:00–8:15 · CIARA
 CUE: REQUIRED PLOT — say 'training and validation loss versus epoch' out loud. The overfitting story is a strength: diagnosed on the interim curve, fixed in the final run shown here.
 SCRIPT:
 This is our training and validation loss versus epoch — the required plot — and it has a story. Our interim run trained a fixed twenty epochs. Validation loss bottomed out at epoch nine and then climbed for eleven epochs while training loss kept falling — textbook overfitting, visible right there in the curve.
@@ -1716,7 +1720,7 @@
           <a:p>
             <a:r>
               <a:rPr lang="en-US" dirty="0"/>
-              <a:t>8:15–9:15 · SPEAKER 3 (suggested: results + demo)
+              <a:t>8:15–9:15 · CHRIS — results + demo (slides 8–14)
 CUE: Make the case that this is the honest way to evaluate. Zeng et al. 2023 if asked why we bothered.
 SCRIPT:
 Before the numbers, the rules. Every prediction is inverse-transformed back to kilowatts, so every error you'll see is in physical units. We report MAE, RMSE, and R² — MAE and RMSE together, because their gap tells you whether the error is spread evenly or concentrated in a few big misses.
@@ -1808,7 +1812,7 @@
           <a:p>
             <a:r>
               <a:rPr lang="en-US" dirty="0"/>
-              <a:t>9:15–10:30 · SPEAKER 3
+              <a:t>9:15–10:30 · CHRIS
 CUE: Lead with 21.8%. The negative-R² observation for seasonal naive is your best 'we actually looked at this' moment.
 SCRIPT:
 The headline: a 21.8 percent RMSE reduction over naive persistence, on five thousand one hundred sixty-five held-out predictions the model never saw in training. MAE 0.306 kilowatts, RMSE 0.449, R² 0.589 — better than every reference forecaster on every metric.

</xml_diff>

<commit_message>
Finalize report, presentation, notebook, and demo updates
</commit_message>
<xml_diff>
--- a/presentation/MSML612_final_presentation.pptx
+++ b/presentation/MSML612_final_presentation.pptx
@@ -797,7 +797,7 @@
               <a:t>14:00–14:30 · SPEAKER 3
 CUE: The evidence the architecture was chosen rather than assumed — real weight under 'difficulty of NN design'.
 SCRIPT:
-Every row here is an independent train-and-evaluate cycle — one design decision changed at a time, everything else held fixed. Three takeaways. The calendar features matter most: dropping them costs more RMSE than any architecture change. More capacity only hurts — doubling depth or width makes things worse, so the constraint is data, not expressiveness, which is why our model is deliberately small. And the Transformer does beat a parameter-matched LSTM — 21.8 versus 20.3 percent skill. A real margin, and an honest one: every configuration in this grid still beats persistence by at least 19.6 percent, so the conclusion doesn't hinge on any single design choice.</a:t>
+Every row here is an independent train-and-evaluate cycle — one design decision changed at a time, everything else held fixed. Three takeaways. The calendar features matter most: dropping them costs more RMSE than any architecture change. More capacity only hurts — doubling depth or width makes things worse, so the constraint is data, not expressiveness, which is why our model is deliberately small. And the Transformer does beat a comparably sized LSTM — 21.8 versus 20.3 percent skill. A real margin, and an honest one: every configuration in this grid still beats persistence by at least 19.6 percent, so the conclusion doesn't hinge on any single design choice.</a:t>
             </a:r>
             <a:endParaRPr lang="en-US" dirty="0"/>
           </a:p>
@@ -1349,8 +1349,8 @@
 CUE: The novelty slide — 3 rubric points. Not 'we used a Transformer'; the argument is attention fits this data for a specific reason, and the evaluation could have proven us wrong.
 SCRIPT:
 Our solution has two halves, and the second is as deliberate as the first.
-The model is an encoder-only Transformer. Why attention for this data? In a recurrent model, information from the far end of the input window reaches the prediction only after passing through twenty-three sequential state updates, decaying at each step. Attention connects any two hours in one step. That matters here because the most informative context is often not the last hour — it's the same hour yesterday, or the same hour last weekend. Attention can put weight directly on those distant positions.
-The second half is the evaluation. We committed upfront to three reference forecasters — persistence, seasonal naive, and the mean — plus an LSTM control with matched parameters, and ablations over every design choice you'll see on the architecture slide. The literature is full of Transformer results that evaporate against simple baselines — Zeng et al. showed that in 2023. So we designed the evaluation to be falsifiable: if attention wasn't earning its complexity here, this setup would have said so.</a:t>
+The model is an encoder-only Transformer. Why attention for this data? In a recurrent model, information from the far end of the input window reaches the prediction only after passing through twenty-three sequential state updates, decaying at each step. Attention connects any two hours in one step. That matters here because the most informative context is often not the last hour. Within our 24-hour window, the model can look back across the full day, including the same hour yesterday.
+The second half is the evaluation. We committed upfront to three reference forecasters — persistence, seasonal naive, and the mean, plus a comparably sized LSTM control, and ablations over the main design choices you'll see on the architecture slide. The literature is full of Transformer results that evaporate against simple baselines — Zeng et al. showed that in 2023. So we designed the evaluation to be falsifiable: if attention wasn't earning its complexity here, this setup would have said so.</a:t>
             </a:r>
             <a:endParaRPr lang="en-US" dirty="0"/>
           </a:p>
@@ -1441,7 +1441,7 @@
               <a:t>4:45–5:15 · SPEAKER 2
 CUE: Move fast. One rubric point; do not dwell.
 SCRIPT:
-Quickly on tooling: PyTorch for the model and training loop, pandas and scikit-learn for the pipeline, matplotlib for figures, and Streamlit for the live demo you'll see in a few minutes. Everything is seeded and pinned, every training run writes a history file, and the whole repo reproduces from two commands — train, evaluate.</a:t>
+Quickly on tooling: PyTorch for the model and training loop, pandas and scikit-learn for the pipeline, matplotlib for figures, and Streamlit for the live demo you'll see in a few minutes. Everything is seeded and version-controlled, every training run writes a history file, and the whole repo reproduces from two commands — train, evaluate.</a:t>
             </a:r>
             <a:endParaRPr lang="en-US" dirty="0"/>
           </a:p>
@@ -1536,7 +1536,7 @@
 Input: a window of 24 hours by 14 features — seven measured, seven calendar. A linear projection lifts each hour to 64 dimensions, so the tensor is batch by 24 by 64. Attention is permutation-invariant — it has no idea hour one comes before hour two — so we add fixed sinusoidal positional encodings; same shape.
 Then two encoder layers. Each has four attention heads — sixteen dimensions per head — a 128-unit feed-forward, and dropout of 0.1. One detail that matters: layer norm goes before each sublayer, not after — pre-norm, from Xiong et al. — which keeps gradients well-conditioned without a warmup schedule.
 Out of the encoder: still batch by 24 by 64. We pool by taking the final time step — batch by 64 — then dropout and a linear head to a single number: next hour's load in standardized units, inverted back to kilowatts for every metric you'll see.
-Total: sixty-eight thousand trainable parameters. That's small on purpose — with thirty-four thousand training hours, a big model overfits long before it underfits, and the capacity ablation confirms it.</a:t>
+Total: sixty-eight thousand trainable parameters. That's small on purpose — with about twenty-four thousand training hours, our larger model variants performed worse, which the capacity ablation confirms.</a:t>
             </a:r>
             <a:endParaRPr lang="en-US" dirty="0"/>
           </a:p>
@@ -2447,7 +2447,7 @@
       </p:sp>
       <p:pic>
         <p:nvPicPr>
-          <p:cNvPr id="3" name="Image 0" descr="C:\Users\chris\Downloads\612-Group-Project\figures\transformer_h1_actual_vs_predicted.png">    </p:cNvPr>
+          <p:cNvPr id="3" name="Image 0" descr="/Users/ciaracameron/Desktop/MSML 612- Deep Learning/612 Group Project/figures/transformer_h1_actual_vs_predicted.png">    </p:cNvPr>
           <p:cNvPicPr>
             <a:picLocks noChangeAspect="1"/>
           </p:cNvPicPr>
@@ -2471,7 +2471,7 @@
       </p:pic>
       <p:pic>
         <p:nvPicPr>
-          <p:cNvPr id="4" name="Image 1" descr="C:\Users\chris\Downloads\612-Group-Project\figures\transformer_h1_error_distribution.png">    </p:cNvPr>
+          <p:cNvPr id="4" name="Image 1" descr="/Users/ciaracameron/Desktop/MSML 612- Deep Learning/612 Group Project/figures/transformer_h1_error_distribution.png">    </p:cNvPr>
           <p:cNvPicPr>
             <a:picLocks noChangeAspect="1"/>
           </p:cNvPicPr>
@@ -2668,7 +2668,7 @@
                 <a:ea typeface="Calibri" pitchFamily="34" charset="-122"/>
                 <a:cs typeface="Calibri" pitchFamily="34" charset="-120"/>
               </a:rPr>
-              <a:t>It is a loss-function artifact, not a capacity failure.</a:t>
+              <a:t>This pattern may be related to the MSE objective, while our capacity ablations suggest that simply making the model larger does not solve it.</a:t>
             </a:r>
             <a:endParaRPr lang="en-US" sz="1150" dirty="0"/>
           </a:p>
@@ -5714,7 +5714,7 @@
                 <a:ea typeface="Calibri" pitchFamily="34" charset="-122"/>
                 <a:cs typeface="Calibri" pitchFamily="34" charset="-120"/>
               </a:rPr>
-              <a:t>Visualise attention weights to test whether the model really attends to the same hour on prior days</a:t>
+              <a:t>Visualize attention weights to see which parts of the previous 24 hours the model relies on most</a:t>
             </a:r>
             <a:endParaRPr lang="en-US" sz="1250" dirty="0"/>
           </a:p>
@@ -7055,7 +7055,7 @@
                 <a:ea typeface="Calibri" pitchFamily="34" charset="-122"/>
                 <a:cs typeface="Calibri" pitchFamily="34" charset="-120"/>
               </a:rPr>
-              <a:t>Combine date/time into a timestamp index, coerce to numeric, drop duplicate timestamps from DST transitions.</a:t>
+              <a:t>Combine date/time into a timestamp index, coerce to numeric, and drop duplicate timestamps.</a:t>
             </a:r>
             <a:endParaRPr lang="en-US" sz="1100" dirty="0"/>
           </a:p>
@@ -7231,7 +7231,7 @@
                 <a:ea typeface="Calibri" pitchFamily="34" charset="-122"/>
                 <a:cs typeface="Calibri" pitchFamily="34" charset="-120"/>
               </a:rPr>
-              <a:t>Minute resolution is noisier than the task needs. Hourly means absorb isolated gaps: 2.08M rows → 34,589 hours.</a:t>
+              <a:t>Convert minute-level readings to hourly means: 2.08M rows → 34,589 hours.</a:t>
             </a:r>
             <a:endParaRPr lang="en-US" sz="1100" dirty="0"/>
           </a:p>
@@ -7368,7 +7368,7 @@
                 <a:ea typeface="Calibri" pitchFamily="34" charset="-122"/>
                 <a:cs typeface="Calibri" pitchFamily="34" charset="-120"/>
               </a:rPr>
-              <a:t>Interpolate</a:t>
+              <a:t>Calendar features</a:t>
             </a:r>
             <a:endParaRPr lang="en-US" sz="1350" dirty="0"/>
           </a:p>
@@ -7407,7 +7407,7 @@
                 <a:ea typeface="Calibri" pitchFamily="34" charset="-122"/>
                 <a:cs typeface="Calibri" pitchFamily="34" charset="-120"/>
               </a:rPr>
-              <a:t>~1.25% of raw rows have missing values. Time-weighted interpolation fills remaining hours without fragmenting the series.</a:t>
+              <a:t>Add sine/cosine encodings of hour, day, and month plus a weekend flag. 7 measured + 7 derived = 14.</a:t>
             </a:r>
             <a:endParaRPr lang="en-US" sz="1100" dirty="0"/>
           </a:p>
@@ -7544,7 +7544,7 @@
                 <a:ea typeface="Calibri" pitchFamily="34" charset="-122"/>
                 <a:cs typeface="Calibri" pitchFamily="34" charset="-120"/>
               </a:rPr>
-              <a:t>Calendar features</a:t>
+              <a:t>Split &amp; interpolate</a:t>
             </a:r>
             <a:endParaRPr lang="en-US" sz="1350" dirty="0"/>
           </a:p>
@@ -7583,7 +7583,7 @@
                 <a:ea typeface="Calibri" pitchFamily="34" charset="-122"/>
                 <a:cs typeface="Calibri" pitchFamily="34" charset="-120"/>
               </a:rPr>
-              <a:t>Hour, day, month as sine/cosine pairs plus weekend flag. Keeps hour 23 adjacent to hour 0. 7 measured + 7 derived = 14.</a:t>
+              <a:t>Split 70/15/15 chronologically, then time-interpolate missing hours independently within each split.</a:t>
             </a:r>
             <a:endParaRPr lang="en-US" sz="1100" dirty="0"/>
           </a:p>
@@ -7720,7 +7720,7 @@
                 <a:ea typeface="Calibri" pitchFamily="34" charset="-122"/>
                 <a:cs typeface="Calibri" pitchFamily="34" charset="-120"/>
               </a:rPr>
-              <a:t>Split, then scale</a:t>
+              <a:t>Scale</a:t>
             </a:r>
             <a:endParaRPr lang="en-US" sz="1350" dirty="0"/>
           </a:p>
@@ -7759,7 +7759,7 @@
                 <a:ea typeface="Calibri" pitchFamily="34" charset="-122"/>
                 <a:cs typeface="Calibri" pitchFamily="34" charset="-120"/>
               </a:rPr>
-              <a:t>70/15/15 chronological. StandardScaler fit on train only — fitting before splitting leaks test statistics.</a:t>
+              <a:t>Fit StandardScaler on training data only; transform validation and test using the training statistics.</a:t>
             </a:r>
             <a:endParaRPr lang="en-US" sz="1100" dirty="0"/>
           </a:p>
@@ -8209,7 +8209,7 @@
                 <a:ea typeface="Calibri" pitchFamily="34" charset="-122"/>
                 <a:cs typeface="Calibri" pitchFamily="34" charset="-120"/>
               </a:rPr>
-              <a:t>Built for the daily cycle</a:t>
+              <a:t>Built for daily patterns</a:t>
             </a:r>
             <a:endParaRPr lang="en-US" sz="1500" dirty="0"/>
           </a:p>
@@ -8248,7 +8248,7 @@
                 <a:ea typeface="Calibri" pitchFamily="34" charset="-122"/>
                 <a:cs typeface="Calibri" pitchFamily="34" charset="-120"/>
               </a:rPr>
-              <a:t>The most informative context is often the same hour on previous days, not the previous hour. Attention represents that directly as a high weight on a distant position.</a:t>
+              <a:t>Electricity use usually follows some type of daily pattern, so the previous hour is not always the most helpful for predicting what comes next. With a 24-hour window, the model can look back across the full day, including the same hour yesterday.</a:t>
             </a:r>
             <a:endParaRPr lang="en-US" sz="1150" dirty="0"/>
           </a:p>
@@ -9258,7 +9258,7 @@
                 <a:ea typeface="Calibri" pitchFamily="34" charset="-122"/>
                 <a:cs typeface="Calibri" pitchFamily="34" charset="-120"/>
               </a:rPr>
-              <a:t>Public repo, pinned requirements, per-run history JSON</a:t>
+              <a:t>Public repo, version-bounded requirements, per-run history JSON</a:t>
             </a:r>
             <a:endParaRPr lang="en-US" sz="1250" dirty="0"/>
           </a:p>
@@ -9330,7 +9330,7 @@
       </p:sp>
       <p:pic>
         <p:nvPicPr>
-          <p:cNvPr id="3" name="Image 0" descr="C:\Users\chris\Downloads\612-Group-Project\figures\architecture.png">    </p:cNvPr>
+          <p:cNvPr id="3" name="Image 0" descr="/Users/ciaracameron/Desktop/MSML 612- Deep Learning/612 Group Project/figures/architecture.png">    </p:cNvPr>
           <p:cNvPicPr>
             <a:picLocks noChangeAspect="1"/>
           </p:cNvPicPr>
@@ -9457,7 +9457,7 @@
       </p:sp>
       <p:pic>
         <p:nvPicPr>
-          <p:cNvPr id="4" name="Image 0" descr="C:\Users\chris\Downloads\612-Group-Project\figures\transformer_h1_loss_curve.png">    </p:cNvPr>
+          <p:cNvPr id="4" name="Image 0" descr="/Users/ciaracameron/Desktop/MSML 612- Deep Learning/612 Group Project/figures/transformer_h1_loss_curve.png">    </p:cNvPr>
           <p:cNvPicPr>
             <a:picLocks noChangeAspect="1"/>
           </p:cNvPicPr>
@@ -12101,7 +12101,7 @@
       </p:sp>
       <p:pic>
         <p:nvPicPr>
-          <p:cNvPr id="11" name="Image 0" descr="C:\Users\chris\Downloads\612-Group-Project\figures\transformer_h1_baseline_comparison.png">    </p:cNvPr>
+          <p:cNvPr id="11" name="Image 0" descr="/Users/ciaracameron/Desktop/MSML 612- Deep Learning/612 Group Project/figures/transformer_h1_baseline_comparison.png">    </p:cNvPr>
           <p:cNvPicPr>
             <a:picLocks noChangeAspect="1"/>
           </p:cNvPicPr>

</xml_diff>